<commit_message>
README: deployed URL and team roles; deck roles match the submission form
</commit_message>
<xml_diff>
--- a/FloodLens_SparkH.pptx
+++ b/FloodLens_SparkH.pptx
@@ -117,53 +117,53 @@
   <p:extLst>
     <p:ext uri="{521415D9-36F7-43E2-AB2F-B90AF26B5E84}">
       <p14:sectionLst xmlns:p14="http://schemas.microsoft.com/office/powerpoint/2010/main">
-        <p14:section name="Cover" id="{64ef36ff-087d-b00f-1d64-66c18c3a5d94}">
+        <p14:section name="Cover" id="{4f53f8fb-de3b-6832-ed67-1040e04f5ccc}">
           <p14:sldIdLst>
             <p14:sldId id="256"/>
           </p14:sldIdLst>
         </p14:section>
-        <p14:section name="Problem" id="{721bde0a-dfc5-6ba3-6bee-0ee48c060d39}">
+        <p14:section name="Problem" id="{0b81bee6-ffe2-7a1d-a33f-d9a70db8bf4f}">
           <p14:sldIdLst>
             <p14:sldId id="257"/>
           </p14:sldIdLst>
         </p14:section>
-        <p14:section name="Data" id="{d4ee5a34-0727-2177-9990-15a1f861dd70}">
+        <p14:section name="Data" id="{bb0732cf-6273-1a66-19e3-c95e4626f039}">
           <p14:sldIdLst>
             <p14:sldId id="258"/>
           </p14:sldIdLst>
         </p14:section>
-        <p14:section name="Pipeline" id="{9b53a0bf-8061-2988-6c37-25650d17cfe9}">
+        <p14:section name="Pipeline" id="{6258888d-52e6-371f-55c1-18d682d52bfa}">
           <p14:sldIdLst>
             <p14:sldId id="259"/>
             <p14:sldId id="260"/>
           </p14:sldIdLst>
         </p14:section>
-        <p14:section name="Agents" id="{ebc3aa7f-fbc4-ddc4-3ade-60aaea9e74a9}">
+        <p14:section name="Agents" id="{ceee7f77-c2e2-c949-4ca4-4126838b00ca}">
           <p14:sldIdLst>
             <p14:sldId id="261"/>
           </p14:sldIdLst>
         </p14:section>
-        <p14:section name="Dashboard" id="{6be4c50c-9d3b-36e1-aaeb-5a327345e395}">
+        <p14:section name="Dashboard" id="{38159228-aef1-cee7-66d4-89c4b4009208}">
           <p14:sldIdLst>
             <p14:sldId id="262"/>
           </p14:sldIdLst>
         </p14:section>
-        <p14:section name="Results" id="{8ab8d926-3443-cf18-cedd-8ffccba44f7f}">
+        <p14:section name="Results" id="{84b3b2fb-b9c6-535e-fd66-9337ca798a8c}">
           <p14:sldIdLst>
             <p14:sldId id="263"/>
           </p14:sldIdLst>
         </p14:section>
-        <p14:section name="Impact" id="{1caf43d1-91b9-be80-5f4e-e68196726319}">
+        <p14:section name="Impact" id="{440afda9-af99-c5e8-a7f5-158d99a26fe9}">
           <p14:sldIdLst>
             <p14:sldId id="264"/>
           </p14:sldIdLst>
         </p14:section>
-        <p14:section name="Conclusion" id="{cbb3e246-414a-c16a-f97b-99a92173ec07}">
+        <p14:section name="Conclusion" id="{41a180aa-6f62-1bd3-cf23-14fb9706d693}">
           <p14:sldIdLst>
             <p14:sldId id="265"/>
           </p14:sldIdLst>
         </p14:section>
-        <p14:section name="Team" id="{75ee3073-d013-a9df-974b-0789ef413038}">
+        <p14:section name="Team" id="{ef3dbe1d-c683-257d-12fd-8ccb195cbe2d}">
           <p14:sldIdLst>
             <p14:sldId id="266"/>
           </p14:sldIdLst>
@@ -3763,7 +3763,7 @@
                   <a:schemeClr val="accent2"/>
                 </a:solidFill>
               </a:rPr>
-              <a:t>Forecast data, models &amp; dashboard</a:t>
+              <a:t>Team Lead · Lead Architect</a:t>
             </a:r>
             <a:endParaRPr lang="en-US" sz="1200" dirty="0"/>
           </a:p>
@@ -3963,7 +3963,7 @@
                   <a:schemeClr val="tx2"/>
                 </a:solidFill>
               </a:rPr>
-              <a:t>Hammad Khan</a:t>
+              <a:t>M Hammad Khan</a:t>
             </a:r>
             <a:endParaRPr lang="en-US" sz="1600" dirty="0"/>
           </a:p>
@@ -3999,7 +3999,7 @@
                   <a:schemeClr val="accent2"/>
                 </a:solidFill>
               </a:rPr>
-              <a:t>Satellite rain &amp; ground truth</a:t>
+              <a:t>Lead Backend</a:t>
             </a:r>
             <a:endParaRPr lang="en-US" sz="1200" dirty="0"/>
           </a:p>
@@ -4199,7 +4199,7 @@
                   <a:schemeClr val="tx2"/>
                 </a:solidFill>
               </a:rPr>
-              <a:t>Muhammad Huzaifa</a:t>
+              <a:t>M Huzaifa</a:t>
             </a:r>
             <a:endParaRPr lang="en-US" sz="1600" dirty="0"/>
           </a:p>
@@ -4235,7 +4235,7 @@
                   <a:schemeClr val="accent2"/>
                 </a:solidFill>
               </a:rPr>
-              <a:t>Deployment &amp; delivery</a:t>
+              <a:t>Lead Data Sources</a:t>
             </a:r>
             <a:endParaRPr lang="en-US" sz="1200" dirty="0"/>
           </a:p>

</xml_diff>

<commit_message>
Deck: correct overstated claims (wind speed, model blend, advisories name areas, calibration wording)
</commit_message>
<xml_diff>
--- a/FloodLens_SparkH.pptx
+++ b/FloodLens_SparkH.pptx
@@ -122,62 +122,62 @@
   <p:extLst>
     <p:ext uri="{521415D9-36F7-43E2-AB2F-B90AF26B5E84}">
       <p14:sectionLst xmlns:p14="http://schemas.microsoft.com/office/powerpoint/2010/main">
-        <p14:section name="Cover" id="{aa3a18de-b0e6-abf7-56b1-4c87834c5c1b}">
+        <p14:section name="Cover" id="{01d8a12b-5fdc-5f7e-f479-655b8f198891}">
           <p14:sldIdLst>
             <p14:sldId id="256"/>
           </p14:sldIdLst>
         </p14:section>
-        <p14:section name="Problem" id="{01d67aa0-3baf-f43e-4bcf-0ec3a9613cac}">
+        <p14:section name="Problem" id="{4435f565-ee12-2c56-f489-87cfdc1a7f92}">
           <p14:sldIdLst>
             <p14:sldId id="257"/>
           </p14:sldIdLst>
         </p14:section>
-        <p14:section name="Data" id="{2b9cf8cc-0b1c-c9db-1522-86ab1e744aaf}">
+        <p14:section name="Data" id="{0ddf81f0-6451-9d82-f651-1f96d35eea40}">
           <p14:sldIdLst>
             <p14:sldId id="258"/>
             <p14:sldId id="259"/>
           </p14:sldIdLst>
         </p14:section>
-        <p14:section name="Pipeline" id="{972a8fa9-bec6-90ef-34cf-924f5cc97cdd}">
+        <p14:section name="Pipeline" id="{5e19b6fe-5c53-4065-f9e7-7e041cf9eeb5}">
           <p14:sldIdLst>
             <p14:sldId id="260"/>
             <p14:sldId id="261"/>
           </p14:sldIdLst>
         </p14:section>
-        <p14:section name="Agents" id="{44e6fc26-c592-8def-12b9-866eb8ba2f8a}">
+        <p14:section name="Agents" id="{d35d06c9-e755-f248-357f-36eeacd62a4f}">
           <p14:sldIdLst>
             <p14:sldId id="262"/>
             <p14:sldId id="263"/>
           </p14:sldIdLst>
         </p14:section>
-        <p14:section name="Dashboard" id="{a3d9a08d-939d-2568-5dd7-fa16f99f8de8}">
+        <p14:section name="Dashboard" id="{01f564f4-a434-4b02-3727-2cfc7399faa6}">
           <p14:sldIdLst>
             <p14:sldId id="264"/>
           </p14:sldIdLst>
         </p14:section>
-        <p14:section name="Results" id="{1f404bd9-23d6-6f56-2c4f-88986e61da05}">
+        <p14:section name="Results" id="{8cb3d5c0-7282-ef76-4425-71909fbc401c}">
           <p14:sldIdLst>
             <p14:sldId id="265"/>
             <p14:sldId id="266"/>
           </p14:sldIdLst>
         </p14:section>
-        <p14:section name="Impact" id="{ec2be030-561f-085c-99b3-7c6a4e3d99dc}">
+        <p14:section name="Impact" id="{756f26b1-0478-7b85-c306-cd4d3ea177a0}">
           <p14:sldIdLst>
             <p14:sldId id="267"/>
           </p14:sldIdLst>
         </p14:section>
-        <p14:section name="Business" id="{67dc6840-a0d9-ce21-b8e9-36fa38afb262}">
+        <p14:section name="Business" id="{b770771c-e939-94c8-d43a-99a494fe1851}">
           <p14:sldIdLst>
             <p14:sldId id="268"/>
             <p14:sldId id="269"/>
           </p14:sldIdLst>
         </p14:section>
-        <p14:section name="Conclusion" id="{539dbb43-5fc8-95ea-5ea6-ee4f4fa10710}">
+        <p14:section name="Conclusion" id="{bfd9a963-1a14-a8e5-f5ba-c9390f6fe738}">
           <p14:sldIdLst>
             <p14:sldId id="270"/>
           </p14:sldIdLst>
         </p14:section>
-        <p14:section name="Team" id="{257b5502-5d56-2a52-808a-a46ec0ede223}">
+        <p14:section name="Team" id="{2c8c96b2-68c6-ce1e-c765-8672f43640a4}">
           <p14:sldIdLst>
             <p14:sldId id="271"/>
           </p14:sldIdLst>
@@ -3445,7 +3445,7 @@
                   <a:schemeClr val="tx1"/>
                 </a:solidFill>
               </a:rPr>
-              <a:t>Platt scaling fitted on the validation period (cross-fitted by week), so a 20% warning means rain like this about 1 time in 5.</a:t>
+              <a:t>Platt scaling fitted on the validation period, never on test, so a 20% warning should mean heavy rain about 1 time in 5.</a:t>
             </a:r>
             <a:endParaRPr lang="en-US" sz="1200" dirty="0"/>
           </a:p>
@@ -5909,7 +5909,7 @@
                             <a:srgbClr val="FFFFFF"/>
                           </a:solidFill>
                         </a:rPr>
-                        <a:t>Provincial alerts &amp; weather apps</a:t>
+                        <a:t>Today: advisories &amp; weather apps</a:t>
                       </a:r>
                       <a:endParaRPr lang="en-US" sz="1300" dirty="0"/>
                     </a:p>
@@ -6091,7 +6091,7 @@
                             <a:srgbClr val="1F2933"/>
                           </a:solidFill>
                         </a:rPr>
-                        <a:t>Often reported once flooding has started</a:t>
+                        <a:t>Advisories issued as events approach</a:t>
                       </a:r>
                       <a:endParaRPr lang="en-US" sz="1300" dirty="0"/>
                     </a:p>
@@ -6149,7 +6149,7 @@
                             <a:srgbClr val="0B5D2A"/>
                           </a:solidFill>
                         </a:rPr>
-                        <a:t>24–72 h ahead, refreshed hourly</a:t>
+                        <a:t>Probabilities 24–72 h ahead, refreshed hourly</a:t>
                       </a:r>
                       <a:endParaRPr lang="en-US" sz="1300" dirty="0"/>
                     </a:p>
@@ -6270,7 +6270,7 @@
                             <a:srgbClr val="1F2933"/>
                           </a:solidFill>
                         </a:rPr>
-                        <a:t>Province or division (“rain in Sindh”)</a:t>
+                        <a:t>Areas listed in words</a:t>
                       </a:r>
                       <a:endParaRPr lang="en-US" sz="1300" dirty="0"/>
                     </a:p>
@@ -6449,7 +6449,7 @@
                             <a:srgbClr val="1F2933"/>
                           </a:solidFill>
                         </a:rPr>
-                        <a:t>Raw forecasts, no stated skill</a:t>
+                        <a:t>No published skill score</a:t>
                       </a:r>
                       <a:endParaRPr lang="en-US" sz="1300" dirty="0"/>
                     </a:p>
@@ -6628,7 +6628,7 @@
                             <a:srgbClr val="1F2933"/>
                           </a:solidFill>
                         </a:rPr>
-                        <a:t>Claims without sources</a:t>
+                        <a:t>Separate PDFs to read and compare</a:t>
                       </a:r>
                       <a:endParaRPr lang="en-US" sz="1300" dirty="0"/>
                     </a:p>
@@ -9871,7 +9871,7 @@
                   <a:schemeClr val="tx1"/>
                 </a:solidFill>
               </a:rPr>
-              <a:t>Alerts are provincial (“heavy rain across KP”); no calibrated per-district chance of rain that is unusual for that district</a:t>
+              <a:t>Advisories list areas in words; none gives each district a calibrated chance of rain that is unusual for it</a:t>
             </a:r>
             <a:endParaRPr lang="en-US" sz="1200" dirty="0"/>
           </a:p>
@@ -10031,7 +10031,7 @@
                   <a:schemeClr val="tx1"/>
                 </a:solidFill>
               </a:rPr>
-              <a:t>Floods cut supply routes and spike staple prices; disaster response and market watch work in silos</a:t>
+              <a:t>Floods can disrupt supply routes and move staple prices; rain alerts and price data sit in separate places</a:t>
             </a:r>
             <a:endParaRPr lang="en-US" sz="1200" dirty="0"/>
           </a:p>
@@ -11403,7 +11403,7 @@
                   <a:schemeClr val="tx1"/>
                 </a:solidFill>
               </a:rPr>
-              <a:t>Previous Runs API: ECMWF, NOAA and DWD forecasts exactly as issued 1, 2 and 3 days ahead</a:t>
+              <a:t>Previous Runs API: weather-model forecasts exactly as issued 1, 2 and 3 days ahead</a:t>
             </a:r>
             <a:endParaRPr lang="en-US" sz="1350" dirty="0"/>
           </a:p>
@@ -11421,7 +11421,7 @@
                   <a:schemeClr val="tx1"/>
                 </a:solidFill>
               </a:rPr>
-              <a:t>Rain sum, max hourly rain, humidity, pressure, cloud cover, wind gusts</a:t>
+              <a:t>Rain sum, max hourly rain, humidity, pressure, cloud cover, wind speed</a:t>
             </a:r>
             <a:endParaRPr lang="en-US" sz="1350" dirty="0"/>
           </a:p>
@@ -11560,7 +11560,7 @@
                   <a:schemeClr val="tx1"/>
                 </a:solidFill>
               </a:rPr>
-              <a:t>Why not gauges? Pakistan's gauges are sparse in the remote, flood-prone districts; satellites cover all 160</a:t>
+              <a:t>Why not gauges? Rain gauges are sparse in many remote districts; satellites cover all 160 evenly</a:t>
             </a:r>
             <a:endParaRPr lang="en-US" sz="1350" dirty="0"/>
           </a:p>

</xml_diff>

<commit_message>
Test window stated as run: 1 Jan to 16 Oct 2026 (script had no end date); numbers unchanged
</commit_message>
<xml_diff>
--- a/FloodLens_SparkH.pptx
+++ b/FloodLens_SparkH.pptx
@@ -122,62 +122,62 @@
   <p:extLst>
     <p:ext uri="{521415D9-36F7-43E2-AB2F-B90AF26B5E84}">
       <p14:sectionLst xmlns:p14="http://schemas.microsoft.com/office/powerpoint/2010/main">
-        <p14:section name="Cover" id="{01d8a12b-5fdc-5f7e-f479-655b8f198891}">
+        <p14:section name="Cover" id="{fa24fe71-777c-dacb-f5e4-f67d83feac7e}">
           <p14:sldIdLst>
             <p14:sldId id="256"/>
           </p14:sldIdLst>
         </p14:section>
-        <p14:section name="Problem" id="{4435f565-ee12-2c56-f489-87cfdc1a7f92}">
+        <p14:section name="Problem" id="{7a439515-f095-f631-2696-b9e28d36dcfb}">
           <p14:sldIdLst>
             <p14:sldId id="257"/>
           </p14:sldIdLst>
         </p14:section>
-        <p14:section name="Data" id="{0ddf81f0-6451-9d82-f651-1f96d35eea40}">
+        <p14:section name="Data" id="{d6347614-b07a-7bc2-f3a0-8bd9fa1a08e5}">
           <p14:sldIdLst>
             <p14:sldId id="258"/>
             <p14:sldId id="259"/>
           </p14:sldIdLst>
         </p14:section>
-        <p14:section name="Pipeline" id="{5e19b6fe-5c53-4065-f9e7-7e041cf9eeb5}">
+        <p14:section name="Pipeline" id="{7dfccdba-76a2-557f-3aff-41c615e7a6a8}">
           <p14:sldIdLst>
             <p14:sldId id="260"/>
             <p14:sldId id="261"/>
           </p14:sldIdLst>
         </p14:section>
-        <p14:section name="Agents" id="{d35d06c9-e755-f248-357f-36eeacd62a4f}">
+        <p14:section name="Agents" id="{408a5390-9c59-e75d-9f1a-d8bcd6117719}">
           <p14:sldIdLst>
             <p14:sldId id="262"/>
             <p14:sldId id="263"/>
           </p14:sldIdLst>
         </p14:section>
-        <p14:section name="Dashboard" id="{01f564f4-a434-4b02-3727-2cfc7399faa6}">
+        <p14:section name="Dashboard" id="{3479e009-7c2e-abca-2204-ad0616143e4d}">
           <p14:sldIdLst>
             <p14:sldId id="264"/>
           </p14:sldIdLst>
         </p14:section>
-        <p14:section name="Results" id="{8cb3d5c0-7282-ef76-4425-71909fbc401c}">
+        <p14:section name="Results" id="{e1313b1c-82c6-0bb7-479d-2547e1a9e0b9}">
           <p14:sldIdLst>
             <p14:sldId id="265"/>
             <p14:sldId id="266"/>
           </p14:sldIdLst>
         </p14:section>
-        <p14:section name="Impact" id="{756f26b1-0478-7b85-c306-cd4d3ea177a0}">
+        <p14:section name="Impact" id="{2bd37b05-0865-2ef1-d373-bf58c3dbea5b}">
           <p14:sldIdLst>
             <p14:sldId id="267"/>
           </p14:sldIdLst>
         </p14:section>
-        <p14:section name="Business" id="{b770771c-e939-94c8-d43a-99a494fe1851}">
+        <p14:section name="Business" id="{3d02030f-3475-d4ff-829b-f1e2e1c58531}">
           <p14:sldIdLst>
             <p14:sldId id="268"/>
             <p14:sldId id="269"/>
           </p14:sldIdLst>
         </p14:section>
-        <p14:section name="Conclusion" id="{bfd9a963-1a14-a8e5-f5ba-c9390f6fe738}">
+        <p14:section name="Conclusion" id="{2f893800-0697-0a85-88e2-815cb840c9b1}">
           <p14:sldIdLst>
             <p14:sldId id="270"/>
           </p14:sldIdLst>
         </p14:section>
-        <p14:section name="Team" id="{2c8c96b2-68c6-ce1e-c765-8672f43640a4}">
+        <p14:section name="Team" id="{bcc90c47-d07f-5746-40bd-d982beabfdb2}">
           <p14:sldIdLst>
             <p14:sldId id="271"/>
           </p14:sldIdLst>
@@ -3654,7 +3654,7 @@
                   <a:schemeClr val="bg1"/>
                 </a:solidFill>
               </a:rPr>
-              <a:t>train to 30 Jun 2025 · validate Jul–Dec 2025 · test Jan–Sep 2026, run once with the frozen model. Baseline declared in advance: district-by-month climatology.</a:t>
+              <a:t>train to 30 Jun 2025 · validate Jul–Dec 2025 · test 1 Jan–16 Oct 2026, run once with the frozen model. Baseline declared in advance: district-by-month climatology.</a:t>
             </a:r>
             <a:endParaRPr lang="en-US" sz="1300" dirty="0"/>
           </a:p>
@@ -3798,7 +3798,7 @@
                   <a:schemeClr val="accent2"/>
                 </a:solidFill>
               </a:rPr>
-              <a:t>TEST SET Jan–Sep 2026, run once · Brier [95% CI], lower is better</a:t>
+              <a:t>TEST SET 1 Jan–16 Oct 2026, run once · Brier [95% CI], lower is better</a:t>
             </a:r>
             <a:endParaRPr lang="en-US" sz="1200" dirty="0"/>
           </a:p>

</xml_diff>